<commit_message>
feat: redesign the sales deck with a title panel, pull quotes, and a blank solve table
Co-authored-by: VedantKachhawa <VedantKachhawa@users.noreply.github.com>
</commit_message>
<xml_diff>
--- a/backend/assets/template.pptx
+++ b/backend/assets/template.pptx
@@ -3089,7 +3089,7 @@
     <p:bg>
       <p:bgPr>
         <a:solidFill>
-          <a:srgbClr val="F6F4EF"/>
+          <a:srgbClr val="F7F5F0"/>
         </a:solidFill>
         <a:effectLst/>
       </p:bgPr>
@@ -3110,17 +3110,18 @@
         <p:spPr>
           <a:xfrm>
             <a:off x="0" y="0"/>
-            <a:ext cx="109728" cy="6858000"/>
+            <a:ext cx="6583680" cy="6858000"/>
           </a:xfrm>
           <a:prstGeom prst="rect">
             <a:avLst/>
           </a:prstGeom>
           <a:solidFill>
-            <a:srgbClr val="14324A"/>
+            <a:srgbClr val="17324D"/>
           </a:solidFill>
           <a:ln>
             <a:noFill/>
           </a:ln>
+          <a:effectLst/>
         </p:spPr>
         <p:style>
           <a:lnRef idx="1">
@@ -3146,64 +3147,14 @@
       </p:sp>
       <p:sp>
         <p:nvSpPr>
-          <p:cNvPr id="3" name="title_text"/>
-          <p:cNvSpPr txBox="1"/>
-          <p:nvPr/>
-        </p:nvSpPr>
-        <p:spPr>
-          <a:xfrm>
-            <a:off x="502920" y="256032"/>
-            <a:ext cx="9509760" cy="713232"/>
-          </a:xfrm>
-          <a:prstGeom prst="rect">
-            <a:avLst/>
-          </a:prstGeom>
-          <a:noFill/>
-          <a:ln>
-            <a:noFill/>
-          </a:ln>
-        </p:spPr>
-        <p:txBody>
-          <a:bodyPr wrap="square" anchor="t"/>
-          <a:lstStyle/>
-          <a:p/>
-        </p:txBody>
-      </p:sp>
-      <p:sp>
-        <p:nvSpPr>
-          <p:cNvPr id="4" name="tag_text"/>
-          <p:cNvSpPr txBox="1"/>
-          <p:nvPr/>
-        </p:nvSpPr>
-        <p:spPr>
-          <a:xfrm>
-            <a:off x="502920" y="987552"/>
-            <a:ext cx="7772400" cy="292608"/>
-          </a:xfrm>
-          <a:prstGeom prst="rect">
-            <a:avLst/>
-          </a:prstGeom>
-          <a:noFill/>
-          <a:ln>
-            <a:noFill/>
-          </a:ln>
-        </p:spPr>
-        <p:txBody>
-          <a:bodyPr wrap="square" anchor="t"/>
-          <a:lstStyle/>
-          <a:p/>
-        </p:txBody>
-      </p:sp>
-      <p:sp>
-        <p:nvSpPr>
-          <p:cNvPr id="5" name="divider"/>
+          <p:cNvPr id="3" name="divider"/>
           <p:cNvSpPr/>
           <p:nvPr/>
         </p:nvSpPr>
         <p:spPr>
           <a:xfrm>
-            <a:off x="502920" y="1335024"/>
-            <a:ext cx="2103120" cy="54864"/>
+            <a:off x="6583680" y="0"/>
+            <a:ext cx="64008" cy="6858000"/>
           </a:xfrm>
           <a:prstGeom prst="rect">
             <a:avLst/>
@@ -3214,6 +3165,7 @@
           <a:ln>
             <a:noFill/>
           </a:ln>
+          <a:effectLst/>
         </p:spPr>
         <p:style>
           <a:lnRef idx="1">
@@ -3239,14 +3191,14 @@
       </p:sp>
       <p:sp>
         <p:nvSpPr>
-          <p:cNvPr id="6" name="body_text"/>
+          <p:cNvPr id="4" name="tag_text"/>
           <p:cNvSpPr txBox="1"/>
           <p:nvPr/>
         </p:nvSpPr>
         <p:spPr>
           <a:xfrm>
             <a:off x="502920" y="1554480"/>
-            <a:ext cx="11064240" cy="3520440"/>
+            <a:ext cx="5577840" cy="292608"/>
           </a:xfrm>
           <a:prstGeom prst="rect">
             <a:avLst/>
@@ -3257,21 +3209,21 @@
           </a:ln>
         </p:spPr>
         <p:txBody>
-          <a:bodyPr wrap="square" anchor="t"/>
+          <a:bodyPr wrap="square" anchor="t" lIns="0" rIns="0" tIns="0" bIns="0"/>
           <a:lstStyle/>
           <a:p/>
         </p:txBody>
       </p:sp>
       <p:sp>
         <p:nvSpPr>
-          <p:cNvPr id="7" name="quote_text"/>
+          <p:cNvPr id="5" name="title_text"/>
           <p:cNvSpPr txBox="1"/>
           <p:nvPr/>
         </p:nvSpPr>
         <p:spPr>
           <a:xfrm>
-            <a:off x="502920" y="5212080"/>
-            <a:ext cx="11064240" cy="1280160"/>
+            <a:off x="502920" y="1965960"/>
+            <a:ext cx="5669280" cy="2148840"/>
           </a:xfrm>
           <a:prstGeom prst="rect">
             <a:avLst/>
@@ -3282,9 +3234,111 @@
           </a:ln>
         </p:spPr>
         <p:txBody>
-          <a:bodyPr wrap="square" anchor="t"/>
+          <a:bodyPr wrap="square" anchor="t" lIns="0" rIns="0" tIns="0" bIns="0"/>
           <a:lstStyle/>
           <a:p/>
+        </p:txBody>
+      </p:sp>
+      <p:sp>
+        <p:nvSpPr>
+          <p:cNvPr id="6" name="body_text"/>
+          <p:cNvSpPr txBox="1"/>
+          <p:nvPr/>
+        </p:nvSpPr>
+        <p:spPr>
+          <a:xfrm>
+            <a:off x="502920" y="4297680"/>
+            <a:ext cx="5623560" cy="1325880"/>
+          </a:xfrm>
+          <a:prstGeom prst="rect">
+            <a:avLst/>
+          </a:prstGeom>
+          <a:noFill/>
+          <a:ln>
+            <a:noFill/>
+          </a:ln>
+        </p:spPr>
+        <p:txBody>
+          <a:bodyPr wrap="square" anchor="t" lIns="0" rIns="0" tIns="0" bIns="0"/>
+          <a:lstStyle/>
+          <a:p/>
+        </p:txBody>
+      </p:sp>
+      <p:sp>
+        <p:nvSpPr>
+          <p:cNvPr id="7" name="quote_text"/>
+          <p:cNvSpPr txBox="1"/>
+          <p:nvPr/>
+        </p:nvSpPr>
+        <p:spPr>
+          <a:xfrm>
+            <a:off x="7040880" y="2331720"/>
+            <a:ext cx="4617720" cy="2377440"/>
+          </a:xfrm>
+          <a:prstGeom prst="rect">
+            <a:avLst/>
+          </a:prstGeom>
+          <a:noFill/>
+          <a:ln>
+            <a:noFill/>
+          </a:ln>
+        </p:spPr>
+        <p:txBody>
+          <a:bodyPr wrap="square" anchor="t" lIns="0" rIns="0" tIns="0" bIns="0"/>
+          <a:lstStyle/>
+          <a:p/>
+        </p:txBody>
+      </p:sp>
+      <p:sp>
+        <p:nvSpPr>
+          <p:cNvPr id="8" name="footer_text"/>
+          <p:cNvSpPr txBox="1"/>
+          <p:nvPr/>
+        </p:nvSpPr>
+        <p:spPr>
+          <a:xfrm>
+            <a:off x="7040880" y="6355080"/>
+            <a:ext cx="3017520" cy="256032"/>
+          </a:xfrm>
+          <a:prstGeom prst="rect">
+            <a:avLst/>
+          </a:prstGeom>
+          <a:noFill/>
+          <a:ln>
+            <a:noFill/>
+          </a:ln>
+        </p:spPr>
+        <p:txBody>
+          <a:bodyPr wrap="square" anchor="t" lIns="0" rIns="0" tIns="0" bIns="0"/>
+          <a:lstStyle/>
+          <a:p/>
+        </p:txBody>
+      </p:sp>
+      <p:sp>
+        <p:nvSpPr>
+          <p:cNvPr id="9" name="slide_number"/>
+          <p:cNvSpPr txBox="1"/>
+          <p:nvPr/>
+        </p:nvSpPr>
+        <p:spPr>
+          <a:xfrm>
+            <a:off x="9966960" y="6355080"/>
+            <a:ext cx="1691640" cy="256032"/>
+          </a:xfrm>
+          <a:prstGeom prst="rect">
+            <a:avLst/>
+          </a:prstGeom>
+          <a:noFill/>
+          <a:ln>
+            <a:noFill/>
+          </a:ln>
+        </p:spPr>
+        <p:txBody>
+          <a:bodyPr wrap="square" anchor="t" lIns="0" rIns="0" tIns="0" bIns="0"/>
+          <a:lstStyle/>
+          <a:p>
+            <a:pPr algn="r"/>
+          </a:p>
         </p:txBody>
       </p:sp>
     </p:spTree>
@@ -3301,7 +3355,7 @@
     <p:bg>
       <p:bgPr>
         <a:solidFill>
-          <a:srgbClr val="F6F4EF"/>
+          <a:srgbClr val="F7F5F0"/>
         </a:solidFill>
         <a:effectLst/>
       </p:bgPr>
@@ -3322,17 +3376,18 @@
         <p:spPr>
           <a:xfrm>
             <a:off x="0" y="0"/>
-            <a:ext cx="109728" cy="6858000"/>
+            <a:ext cx="12191999" cy="73152"/>
           </a:xfrm>
           <a:prstGeom prst="rect">
             <a:avLst/>
           </a:prstGeom>
           <a:solidFill>
-            <a:srgbClr val="14324A"/>
+            <a:srgbClr val="17324D"/>
           </a:solidFill>
           <a:ln>
             <a:noFill/>
           </a:ln>
+          <a:effectLst/>
         </p:spPr>
         <p:style>
           <a:lnRef idx="1">
@@ -3358,14 +3413,14 @@
       </p:sp>
       <p:sp>
         <p:nvSpPr>
-          <p:cNvPr id="3" name="title_text"/>
+          <p:cNvPr id="3" name="tag_text"/>
           <p:cNvSpPr txBox="1"/>
           <p:nvPr/>
         </p:nvSpPr>
         <p:spPr>
           <a:xfrm>
-            <a:off x="502920" y="256032"/>
-            <a:ext cx="9509760" cy="713232"/>
+            <a:off x="566928" y="292608"/>
+            <a:ext cx="10789920" cy="256032"/>
           </a:xfrm>
           <a:prstGeom prst="rect">
             <a:avLst/>
@@ -3376,21 +3431,21 @@
           </a:ln>
         </p:spPr>
         <p:txBody>
-          <a:bodyPr wrap="square" anchor="t"/>
+          <a:bodyPr wrap="square" anchor="t" lIns="0" rIns="0" tIns="0" bIns="0"/>
           <a:lstStyle/>
           <a:p/>
         </p:txBody>
       </p:sp>
       <p:sp>
         <p:nvSpPr>
-          <p:cNvPr id="4" name="tag_text"/>
+          <p:cNvPr id="4" name="title_text"/>
           <p:cNvSpPr txBox="1"/>
           <p:nvPr/>
         </p:nvSpPr>
         <p:spPr>
           <a:xfrm>
-            <a:off x="502920" y="987552"/>
-            <a:ext cx="7772400" cy="292608"/>
+            <a:off x="566928" y="566928"/>
+            <a:ext cx="11018520" cy="868680"/>
           </a:xfrm>
           <a:prstGeom prst="rect">
             <a:avLst/>
@@ -3401,7 +3456,7 @@
           </a:ln>
         </p:spPr>
         <p:txBody>
-          <a:bodyPr wrap="square" anchor="t"/>
+          <a:bodyPr wrap="square" anchor="t" lIns="0" rIns="0" tIns="0" bIns="0"/>
           <a:lstStyle/>
           <a:p/>
         </p:txBody>
@@ -3414,8 +3469,8 @@
         </p:nvSpPr>
         <p:spPr>
           <a:xfrm>
-            <a:off x="502920" y="1335024"/>
-            <a:ext cx="2103120" cy="54864"/>
+            <a:off x="566928" y="1517904"/>
+            <a:ext cx="1417320" cy="41148"/>
           </a:xfrm>
           <a:prstGeom prst="rect">
             <a:avLst/>
@@ -3426,6 +3481,7 @@
           <a:ln>
             <a:noFill/>
           </a:ln>
+          <a:effectLst/>
         </p:spPr>
         <p:style>
           <a:lnRef idx="1">
@@ -3451,14 +3507,14 @@
       </p:sp>
       <p:sp>
         <p:nvSpPr>
-          <p:cNvPr id="6" name="body_text"/>
+          <p:cNvPr id="6" name="footer_text"/>
           <p:cNvSpPr txBox="1"/>
           <p:nvPr/>
         </p:nvSpPr>
         <p:spPr>
           <a:xfrm>
-            <a:off x="502920" y="1554480"/>
-            <a:ext cx="11064240" cy="3520440"/>
+            <a:off x="566928" y="6446520"/>
+            <a:ext cx="7680960" cy="256032"/>
           </a:xfrm>
           <a:prstGeom prst="rect">
             <a:avLst/>
@@ -3469,21 +3525,21 @@
           </a:ln>
         </p:spPr>
         <p:txBody>
-          <a:bodyPr wrap="square" anchor="t"/>
+          <a:bodyPr wrap="square" anchor="t" lIns="0" rIns="0" tIns="0" bIns="0"/>
           <a:lstStyle/>
           <a:p/>
         </p:txBody>
       </p:sp>
       <p:sp>
         <p:nvSpPr>
-          <p:cNvPr id="7" name="quote_text"/>
+          <p:cNvPr id="7" name="slide_number"/>
           <p:cNvSpPr txBox="1"/>
           <p:nvPr/>
         </p:nvSpPr>
         <p:spPr>
           <a:xfrm>
-            <a:off x="502920" y="5212080"/>
-            <a:ext cx="11064240" cy="1280160"/>
+            <a:off x="9281160" y="6446520"/>
+            <a:ext cx="2331720" cy="256032"/>
           </a:xfrm>
           <a:prstGeom prst="rect">
             <a:avLst/>
@@ -3494,7 +3550,103 @@
           </a:ln>
         </p:spPr>
         <p:txBody>
-          <a:bodyPr wrap="square" anchor="t"/>
+          <a:bodyPr wrap="square" anchor="t" lIns="0" rIns="0" tIns="0" bIns="0"/>
+          <a:lstStyle/>
+          <a:p>
+            <a:pPr algn="r"/>
+          </a:p>
+        </p:txBody>
+      </p:sp>
+      <p:sp>
+        <p:nvSpPr>
+          <p:cNvPr id="8" name="body_text"/>
+          <p:cNvSpPr txBox="1"/>
+          <p:nvPr/>
+        </p:nvSpPr>
+        <p:spPr>
+          <a:xfrm>
+            <a:off x="566928" y="1783080"/>
+            <a:ext cx="6720840" cy="4343400"/>
+          </a:xfrm>
+          <a:prstGeom prst="rect">
+            <a:avLst/>
+          </a:prstGeom>
+          <a:noFill/>
+          <a:ln>
+            <a:noFill/>
+          </a:ln>
+        </p:spPr>
+        <p:txBody>
+          <a:bodyPr wrap="square" anchor="t" lIns="0" rIns="0" tIns="0" bIns="0"/>
+          <a:lstStyle/>
+          <a:p/>
+        </p:txBody>
+      </p:sp>
+      <p:sp>
+        <p:nvSpPr>
+          <p:cNvPr id="9" name="quote_panel"/>
+          <p:cNvSpPr/>
+          <p:nvPr/>
+        </p:nvSpPr>
+        <p:spPr>
+          <a:xfrm>
+            <a:off x="7498079" y="1783080"/>
+            <a:ext cx="4114800" cy="4343400"/>
+          </a:xfrm>
+          <a:prstGeom prst="rect">
+            <a:avLst/>
+          </a:prstGeom>
+          <a:solidFill>
+            <a:srgbClr val="FFFFFF"/>
+          </a:solidFill>
+          <a:ln>
+            <a:noFill/>
+          </a:ln>
+          <a:effectLst/>
+        </p:spPr>
+        <p:style>
+          <a:lnRef idx="1">
+            <a:schemeClr val="accent1"/>
+          </a:lnRef>
+          <a:fillRef idx="3">
+            <a:schemeClr val="accent1"/>
+          </a:fillRef>
+          <a:effectRef idx="2">
+            <a:schemeClr val="accent1"/>
+          </a:effectRef>
+          <a:fontRef idx="minor">
+            <a:schemeClr val="lt1"/>
+          </a:fontRef>
+        </p:style>
+        <p:txBody>
+          <a:bodyPr rtlCol="0" anchor="ctr"/>
+          <a:lstStyle/>
+          <a:p>
+            <a:pPr algn="ctr"/>
+          </a:p>
+        </p:txBody>
+      </p:sp>
+      <p:sp>
+        <p:nvSpPr>
+          <p:cNvPr id="10" name="quote_text"/>
+          <p:cNvSpPr txBox="1"/>
+          <p:nvPr/>
+        </p:nvSpPr>
+        <p:spPr>
+          <a:xfrm>
+            <a:off x="7726679" y="1993392"/>
+            <a:ext cx="3703320" cy="3931920"/>
+          </a:xfrm>
+          <a:prstGeom prst="rect">
+            <a:avLst/>
+          </a:prstGeom>
+          <a:noFill/>
+          <a:ln>
+            <a:noFill/>
+          </a:ln>
+        </p:spPr>
+        <p:txBody>
+          <a:bodyPr wrap="square" anchor="t" lIns="0" rIns="0" tIns="0" bIns="0"/>
           <a:lstStyle/>
           <a:p/>
         </p:txBody>
@@ -3513,7 +3665,7 @@
     <p:bg>
       <p:bgPr>
         <a:solidFill>
-          <a:srgbClr val="F6F4EF"/>
+          <a:srgbClr val="F7F5F0"/>
         </a:solidFill>
         <a:effectLst/>
       </p:bgPr>
@@ -3534,17 +3686,18 @@
         <p:spPr>
           <a:xfrm>
             <a:off x="0" y="0"/>
-            <a:ext cx="109728" cy="6858000"/>
+            <a:ext cx="12191999" cy="73152"/>
           </a:xfrm>
           <a:prstGeom prst="rect">
             <a:avLst/>
           </a:prstGeom>
           <a:solidFill>
-            <a:srgbClr val="14324A"/>
+            <a:srgbClr val="17324D"/>
           </a:solidFill>
           <a:ln>
             <a:noFill/>
           </a:ln>
+          <a:effectLst/>
         </p:spPr>
         <p:style>
           <a:lnRef idx="1">
@@ -3570,14 +3723,14 @@
       </p:sp>
       <p:sp>
         <p:nvSpPr>
-          <p:cNvPr id="3" name="title_text"/>
+          <p:cNvPr id="3" name="tag_text"/>
           <p:cNvSpPr txBox="1"/>
           <p:nvPr/>
         </p:nvSpPr>
         <p:spPr>
           <a:xfrm>
-            <a:off x="502920" y="256032"/>
-            <a:ext cx="9509760" cy="713232"/>
+            <a:off x="566928" y="292608"/>
+            <a:ext cx="10789920" cy="256032"/>
           </a:xfrm>
           <a:prstGeom prst="rect">
             <a:avLst/>
@@ -3588,21 +3741,21 @@
           </a:ln>
         </p:spPr>
         <p:txBody>
-          <a:bodyPr wrap="square" anchor="t"/>
+          <a:bodyPr wrap="square" anchor="t" lIns="0" rIns="0" tIns="0" bIns="0"/>
           <a:lstStyle/>
           <a:p/>
         </p:txBody>
       </p:sp>
       <p:sp>
         <p:nvSpPr>
-          <p:cNvPr id="4" name="tag_text"/>
+          <p:cNvPr id="4" name="title_text"/>
           <p:cNvSpPr txBox="1"/>
           <p:nvPr/>
         </p:nvSpPr>
         <p:spPr>
           <a:xfrm>
-            <a:off x="502920" y="987552"/>
-            <a:ext cx="7772400" cy="292608"/>
+            <a:off x="566928" y="566928"/>
+            <a:ext cx="11018520" cy="868680"/>
           </a:xfrm>
           <a:prstGeom prst="rect">
             <a:avLst/>
@@ -3613,7 +3766,7 @@
           </a:ln>
         </p:spPr>
         <p:txBody>
-          <a:bodyPr wrap="square" anchor="t"/>
+          <a:bodyPr wrap="square" anchor="t" lIns="0" rIns="0" tIns="0" bIns="0"/>
           <a:lstStyle/>
           <a:p/>
         </p:txBody>
@@ -3626,8 +3779,8 @@
         </p:nvSpPr>
         <p:spPr>
           <a:xfrm>
-            <a:off x="502920" y="1335024"/>
-            <a:ext cx="2103120" cy="54864"/>
+            <a:off x="566928" y="1517904"/>
+            <a:ext cx="1417320" cy="41148"/>
           </a:xfrm>
           <a:prstGeom prst="rect">
             <a:avLst/>
@@ -3638,6 +3791,7 @@
           <a:ln>
             <a:noFill/>
           </a:ln>
+          <a:effectLst/>
         </p:spPr>
         <p:style>
           <a:lnRef idx="1">
@@ -3663,14 +3817,14 @@
       </p:sp>
       <p:sp>
         <p:nvSpPr>
-          <p:cNvPr id="6" name="body_text"/>
+          <p:cNvPr id="6" name="footer_text"/>
           <p:cNvSpPr txBox="1"/>
           <p:nvPr/>
         </p:nvSpPr>
         <p:spPr>
           <a:xfrm>
-            <a:off x="502920" y="1554480"/>
-            <a:ext cx="11064240" cy="3520440"/>
+            <a:off x="566928" y="6446520"/>
+            <a:ext cx="7680960" cy="256032"/>
           </a:xfrm>
           <a:prstGeom prst="rect">
             <a:avLst/>
@@ -3681,21 +3835,21 @@
           </a:ln>
         </p:spPr>
         <p:txBody>
-          <a:bodyPr wrap="square" anchor="t"/>
+          <a:bodyPr wrap="square" anchor="t" lIns="0" rIns="0" tIns="0" bIns="0"/>
           <a:lstStyle/>
           <a:p/>
         </p:txBody>
       </p:sp>
       <p:sp>
         <p:nvSpPr>
-          <p:cNvPr id="7" name="quote_text"/>
+          <p:cNvPr id="7" name="slide_number"/>
           <p:cNvSpPr txBox="1"/>
           <p:nvPr/>
         </p:nvSpPr>
         <p:spPr>
           <a:xfrm>
-            <a:off x="502920" y="5212080"/>
-            <a:ext cx="11064240" cy="1280160"/>
+            <a:off x="9281160" y="6446520"/>
+            <a:ext cx="2331720" cy="256032"/>
           </a:xfrm>
           <a:prstGeom prst="rect">
             <a:avLst/>
@@ -3706,7 +3860,132 @@
           </a:ln>
         </p:spPr>
         <p:txBody>
-          <a:bodyPr wrap="square" anchor="t"/>
+          <a:bodyPr wrap="square" anchor="t" lIns="0" rIns="0" tIns="0" bIns="0"/>
+          <a:lstStyle/>
+          <a:p>
+            <a:pPr algn="r"/>
+          </a:p>
+        </p:txBody>
+      </p:sp>
+      <p:sp>
+        <p:nvSpPr>
+          <p:cNvPr id="8" name="body_text"/>
+          <p:cNvSpPr txBox="1"/>
+          <p:nvPr/>
+        </p:nvSpPr>
+        <p:spPr>
+          <a:xfrm>
+            <a:off x="566928" y="1737360"/>
+            <a:ext cx="11018520" cy="1554480"/>
+          </a:xfrm>
+          <a:prstGeom prst="rect">
+            <a:avLst/>
+          </a:prstGeom>
+          <a:noFill/>
+          <a:ln>
+            <a:noFill/>
+          </a:ln>
+        </p:spPr>
+        <p:txBody>
+          <a:bodyPr wrap="square" anchor="t" lIns="0" rIns="0" tIns="0" bIns="0"/>
+          <a:lstStyle/>
+          <a:p/>
+        </p:txBody>
+      </p:sp>
+      <p:sp>
+        <p:nvSpPr>
+          <p:cNvPr id="9" name="quote_panel"/>
+          <p:cNvSpPr/>
+          <p:nvPr/>
+        </p:nvSpPr>
+        <p:spPr>
+          <a:xfrm>
+            <a:off x="566928" y="3520440"/>
+            <a:ext cx="11018520" cy="2651760"/>
+          </a:xfrm>
+          <a:prstGeom prst="rect">
+            <a:avLst/>
+          </a:prstGeom>
+          <a:solidFill>
+            <a:srgbClr val="FFFFFF"/>
+          </a:solidFill>
+          <a:ln>
+            <a:noFill/>
+          </a:ln>
+          <a:effectLst/>
+        </p:spPr>
+        <p:style>
+          <a:lnRef idx="1">
+            <a:schemeClr val="accent1"/>
+          </a:lnRef>
+          <a:fillRef idx="3">
+            <a:schemeClr val="accent1"/>
+          </a:fillRef>
+          <a:effectRef idx="2">
+            <a:schemeClr val="accent1"/>
+          </a:effectRef>
+          <a:fontRef idx="minor">
+            <a:schemeClr val="lt1"/>
+          </a:fontRef>
+        </p:style>
+        <p:txBody>
+          <a:bodyPr rtlCol="0" anchor="ctr"/>
+          <a:lstStyle/>
+          <a:p>
+            <a:pPr algn="ctr"/>
+          </a:p>
+        </p:txBody>
+      </p:sp>
+      <p:sp>
+        <p:nvSpPr>
+          <p:cNvPr id="10" name="quote_mark"/>
+          <p:cNvSpPr txBox="1"/>
+          <p:nvPr/>
+        </p:nvSpPr>
+        <p:spPr>
+          <a:xfrm>
+            <a:off x="749808" y="3611880"/>
+            <a:ext cx="640080" cy="548640"/>
+          </a:xfrm>
+          <a:prstGeom prst="rect">
+            <a:avLst/>
+          </a:prstGeom>
+          <a:noFill/>
+          <a:ln>
+            <a:noFill/>
+          </a:ln>
+        </p:spPr>
+        <p:txBody>
+          <a:bodyPr wrap="square" anchor="t" lIns="0" rIns="0" tIns="0" bIns="0"/>
+          <a:lstStyle/>
+          <a:p>
+            <a:r>
+              <a:t>“</a:t>
+            </a:r>
+          </a:p>
+        </p:txBody>
+      </p:sp>
+      <p:sp>
+        <p:nvSpPr>
+          <p:cNvPr id="11" name="quote_text"/>
+          <p:cNvSpPr txBox="1"/>
+          <p:nvPr/>
+        </p:nvSpPr>
+        <p:spPr>
+          <a:xfrm>
+            <a:off x="1325880" y="3794760"/>
+            <a:ext cx="9921240" cy="2148840"/>
+          </a:xfrm>
+          <a:prstGeom prst="rect">
+            <a:avLst/>
+          </a:prstGeom>
+          <a:noFill/>
+          <a:ln>
+            <a:noFill/>
+          </a:ln>
+        </p:spPr>
+        <p:txBody>
+          <a:bodyPr wrap="square" anchor="t" lIns="0" rIns="0" tIns="0" bIns="0"/>
           <a:lstStyle/>
           <a:p/>
         </p:txBody>
@@ -3725,7 +4004,7 @@
     <p:bg>
       <p:bgPr>
         <a:solidFill>
-          <a:srgbClr val="F6F4EF"/>
+          <a:srgbClr val="F7F5F0"/>
         </a:solidFill>
         <a:effectLst/>
       </p:bgPr>
@@ -3746,17 +4025,18 @@
         <p:spPr>
           <a:xfrm>
             <a:off x="0" y="0"/>
-            <a:ext cx="109728" cy="6858000"/>
+            <a:ext cx="12191999" cy="73152"/>
           </a:xfrm>
           <a:prstGeom prst="rect">
             <a:avLst/>
           </a:prstGeom>
           <a:solidFill>
-            <a:srgbClr val="14324A"/>
+            <a:srgbClr val="17324D"/>
           </a:solidFill>
           <a:ln>
             <a:noFill/>
           </a:ln>
+          <a:effectLst/>
         </p:spPr>
         <p:style>
           <a:lnRef idx="1">
@@ -3782,14 +4062,14 @@
       </p:sp>
       <p:sp>
         <p:nvSpPr>
-          <p:cNvPr id="3" name="title_text"/>
+          <p:cNvPr id="3" name="tag_text"/>
           <p:cNvSpPr txBox="1"/>
           <p:nvPr/>
         </p:nvSpPr>
         <p:spPr>
           <a:xfrm>
-            <a:off x="502920" y="256032"/>
-            <a:ext cx="9509760" cy="713232"/>
+            <a:off x="566928" y="292608"/>
+            <a:ext cx="10789920" cy="256032"/>
           </a:xfrm>
           <a:prstGeom prst="rect">
             <a:avLst/>
@@ -3800,21 +4080,21 @@
           </a:ln>
         </p:spPr>
         <p:txBody>
-          <a:bodyPr wrap="square" anchor="t"/>
+          <a:bodyPr wrap="square" anchor="t" lIns="0" rIns="0" tIns="0" bIns="0"/>
           <a:lstStyle/>
           <a:p/>
         </p:txBody>
       </p:sp>
       <p:sp>
         <p:nvSpPr>
-          <p:cNvPr id="4" name="tag_text"/>
+          <p:cNvPr id="4" name="title_text"/>
           <p:cNvSpPr txBox="1"/>
           <p:nvPr/>
         </p:nvSpPr>
         <p:spPr>
           <a:xfrm>
-            <a:off x="502920" y="987552"/>
-            <a:ext cx="7772400" cy="292608"/>
+            <a:off x="566928" y="566928"/>
+            <a:ext cx="11018520" cy="868680"/>
           </a:xfrm>
           <a:prstGeom prst="rect">
             <a:avLst/>
@@ -3825,7 +4105,7 @@
           </a:ln>
         </p:spPr>
         <p:txBody>
-          <a:bodyPr wrap="square" anchor="t"/>
+          <a:bodyPr wrap="square" anchor="t" lIns="0" rIns="0" tIns="0" bIns="0"/>
           <a:lstStyle/>
           <a:p/>
         </p:txBody>
@@ -3838,8 +4118,8 @@
         </p:nvSpPr>
         <p:spPr>
           <a:xfrm>
-            <a:off x="502920" y="1335024"/>
-            <a:ext cx="2103120" cy="54864"/>
+            <a:off x="566928" y="1517904"/>
+            <a:ext cx="1417320" cy="41148"/>
           </a:xfrm>
           <a:prstGeom prst="rect">
             <a:avLst/>
@@ -3850,6 +4130,7 @@
           <a:ln>
             <a:noFill/>
           </a:ln>
+          <a:effectLst/>
         </p:spPr>
         <p:style>
           <a:lnRef idx="1">
@@ -3875,14 +4156,14 @@
       </p:sp>
       <p:sp>
         <p:nvSpPr>
-          <p:cNvPr id="6" name="body_text"/>
+          <p:cNvPr id="6" name="footer_text"/>
           <p:cNvSpPr txBox="1"/>
           <p:nvPr/>
         </p:nvSpPr>
         <p:spPr>
           <a:xfrm>
-            <a:off x="502920" y="1554480"/>
-            <a:ext cx="11064240" cy="3520440"/>
+            <a:off x="566928" y="6446520"/>
+            <a:ext cx="7680960" cy="256032"/>
           </a:xfrm>
           <a:prstGeom prst="rect">
             <a:avLst/>
@@ -3893,21 +4174,21 @@
           </a:ln>
         </p:spPr>
         <p:txBody>
-          <a:bodyPr wrap="square" anchor="t"/>
+          <a:bodyPr wrap="square" anchor="t" lIns="0" rIns="0" tIns="0" bIns="0"/>
           <a:lstStyle/>
           <a:p/>
         </p:txBody>
       </p:sp>
       <p:sp>
         <p:nvSpPr>
-          <p:cNvPr id="7" name="quote_text"/>
+          <p:cNvPr id="7" name="slide_number"/>
           <p:cNvSpPr txBox="1"/>
           <p:nvPr/>
         </p:nvSpPr>
         <p:spPr>
           <a:xfrm>
-            <a:off x="502920" y="5212080"/>
-            <a:ext cx="11064240" cy="1280160"/>
+            <a:off x="9281160" y="6446520"/>
+            <a:ext cx="2331720" cy="256032"/>
           </a:xfrm>
           <a:prstGeom prst="rect">
             <a:avLst/>
@@ -3918,7 +4199,59 @@
           </a:ln>
         </p:spPr>
         <p:txBody>
-          <a:bodyPr wrap="square" anchor="t"/>
+          <a:bodyPr wrap="square" anchor="t" lIns="0" rIns="0" tIns="0" bIns="0"/>
+          <a:lstStyle/>
+          <a:p>
+            <a:pPr algn="r"/>
+          </a:p>
+        </p:txBody>
+      </p:sp>
+      <p:sp>
+        <p:nvSpPr>
+          <p:cNvPr id="8" name="body_text"/>
+          <p:cNvSpPr txBox="1"/>
+          <p:nvPr/>
+        </p:nvSpPr>
+        <p:spPr>
+          <a:xfrm>
+            <a:off x="566928" y="1719072"/>
+            <a:ext cx="11018520" cy="502920"/>
+          </a:xfrm>
+          <a:prstGeom prst="rect">
+            <a:avLst/>
+          </a:prstGeom>
+          <a:noFill/>
+          <a:ln>
+            <a:noFill/>
+          </a:ln>
+        </p:spPr>
+        <p:txBody>
+          <a:bodyPr wrap="square" anchor="t" lIns="0" rIns="0" tIns="0" bIns="0"/>
+          <a:lstStyle/>
+          <a:p/>
+        </p:txBody>
+      </p:sp>
+      <p:sp>
+        <p:nvSpPr>
+          <p:cNvPr id="9" name="quote_text"/>
+          <p:cNvSpPr txBox="1"/>
+          <p:nvPr/>
+        </p:nvSpPr>
+        <p:spPr>
+          <a:xfrm>
+            <a:off x="566928" y="5989320"/>
+            <a:ext cx="11018520" cy="347472"/>
+          </a:xfrm>
+          <a:prstGeom prst="rect">
+            <a:avLst/>
+          </a:prstGeom>
+          <a:noFill/>
+          <a:ln>
+            <a:noFill/>
+          </a:ln>
+        </p:spPr>
+        <p:txBody>
+          <a:bodyPr wrap="square" anchor="t" lIns="0" rIns="0" tIns="0" bIns="0"/>
           <a:lstStyle/>
           <a:p/>
         </p:txBody>
@@ -3937,7 +4270,7 @@
     <p:bg>
       <p:bgPr>
         <a:solidFill>
-          <a:srgbClr val="F6F4EF"/>
+          <a:srgbClr val="F7F5F0"/>
         </a:solidFill>
         <a:effectLst/>
       </p:bgPr>
@@ -3958,17 +4291,18 @@
         <p:spPr>
           <a:xfrm>
             <a:off x="0" y="0"/>
-            <a:ext cx="109728" cy="6858000"/>
+            <a:ext cx="12191999" cy="73152"/>
           </a:xfrm>
           <a:prstGeom prst="rect">
             <a:avLst/>
           </a:prstGeom>
           <a:solidFill>
-            <a:srgbClr val="14324A"/>
+            <a:srgbClr val="17324D"/>
           </a:solidFill>
           <a:ln>
             <a:noFill/>
           </a:ln>
+          <a:effectLst/>
         </p:spPr>
         <p:style>
           <a:lnRef idx="1">
@@ -3994,14 +4328,14 @@
       </p:sp>
       <p:sp>
         <p:nvSpPr>
-          <p:cNvPr id="3" name="title_text"/>
+          <p:cNvPr id="3" name="tag_text"/>
           <p:cNvSpPr txBox="1"/>
           <p:nvPr/>
         </p:nvSpPr>
         <p:spPr>
           <a:xfrm>
-            <a:off x="502920" y="256032"/>
-            <a:ext cx="9509760" cy="713232"/>
+            <a:off x="566928" y="292608"/>
+            <a:ext cx="10789920" cy="256032"/>
           </a:xfrm>
           <a:prstGeom prst="rect">
             <a:avLst/>
@@ -4012,21 +4346,21 @@
           </a:ln>
         </p:spPr>
         <p:txBody>
-          <a:bodyPr wrap="square" anchor="t"/>
+          <a:bodyPr wrap="square" anchor="t" lIns="0" rIns="0" tIns="0" bIns="0"/>
           <a:lstStyle/>
           <a:p/>
         </p:txBody>
       </p:sp>
       <p:sp>
         <p:nvSpPr>
-          <p:cNvPr id="4" name="tag_text"/>
+          <p:cNvPr id="4" name="title_text"/>
           <p:cNvSpPr txBox="1"/>
           <p:nvPr/>
         </p:nvSpPr>
         <p:spPr>
           <a:xfrm>
-            <a:off x="502920" y="987552"/>
-            <a:ext cx="7772400" cy="292608"/>
+            <a:off x="566928" y="566928"/>
+            <a:ext cx="11018520" cy="868680"/>
           </a:xfrm>
           <a:prstGeom prst="rect">
             <a:avLst/>
@@ -4037,7 +4371,7 @@
           </a:ln>
         </p:spPr>
         <p:txBody>
-          <a:bodyPr wrap="square" anchor="t"/>
+          <a:bodyPr wrap="square" anchor="t" lIns="0" rIns="0" tIns="0" bIns="0"/>
           <a:lstStyle/>
           <a:p/>
         </p:txBody>
@@ -4050,8 +4384,8 @@
         </p:nvSpPr>
         <p:spPr>
           <a:xfrm>
-            <a:off x="502920" y="1335024"/>
-            <a:ext cx="2103120" cy="54864"/>
+            <a:off x="566928" y="1517904"/>
+            <a:ext cx="1417320" cy="41148"/>
           </a:xfrm>
           <a:prstGeom prst="rect">
             <a:avLst/>
@@ -4062,6 +4396,7 @@
           <a:ln>
             <a:noFill/>
           </a:ln>
+          <a:effectLst/>
         </p:spPr>
         <p:style>
           <a:lnRef idx="1">
@@ -4087,14 +4422,14 @@
       </p:sp>
       <p:sp>
         <p:nvSpPr>
-          <p:cNvPr id="6" name="body_text"/>
+          <p:cNvPr id="6" name="footer_text"/>
           <p:cNvSpPr txBox="1"/>
           <p:nvPr/>
         </p:nvSpPr>
         <p:spPr>
           <a:xfrm>
-            <a:off x="502920" y="1554480"/>
-            <a:ext cx="11064240" cy="3520440"/>
+            <a:off x="566928" y="6446520"/>
+            <a:ext cx="7680960" cy="256032"/>
           </a:xfrm>
           <a:prstGeom prst="rect">
             <a:avLst/>
@@ -4105,21 +4440,21 @@
           </a:ln>
         </p:spPr>
         <p:txBody>
-          <a:bodyPr wrap="square" anchor="t"/>
+          <a:bodyPr wrap="square" anchor="t" lIns="0" rIns="0" tIns="0" bIns="0"/>
           <a:lstStyle/>
           <a:p/>
         </p:txBody>
       </p:sp>
       <p:sp>
         <p:nvSpPr>
-          <p:cNvPr id="7" name="quote_text"/>
+          <p:cNvPr id="7" name="slide_number"/>
           <p:cNvSpPr txBox="1"/>
           <p:nvPr/>
         </p:nvSpPr>
         <p:spPr>
           <a:xfrm>
-            <a:off x="502920" y="5212080"/>
-            <a:ext cx="11064240" cy="1280160"/>
+            <a:off x="9281160" y="6446520"/>
+            <a:ext cx="2331720" cy="256032"/>
           </a:xfrm>
           <a:prstGeom prst="rect">
             <a:avLst/>
@@ -4130,7 +4465,59 @@
           </a:ln>
         </p:spPr>
         <p:txBody>
-          <a:bodyPr wrap="square" anchor="t"/>
+          <a:bodyPr wrap="square" anchor="t" lIns="0" rIns="0" tIns="0" bIns="0"/>
+          <a:lstStyle/>
+          <a:p>
+            <a:pPr algn="r"/>
+          </a:p>
+        </p:txBody>
+      </p:sp>
+      <p:sp>
+        <p:nvSpPr>
+          <p:cNvPr id="8" name="body_text"/>
+          <p:cNvSpPr txBox="1"/>
+          <p:nvPr/>
+        </p:nvSpPr>
+        <p:spPr>
+          <a:xfrm>
+            <a:off x="566928" y="1783080"/>
+            <a:ext cx="11018520" cy="3794760"/>
+          </a:xfrm>
+          <a:prstGeom prst="rect">
+            <a:avLst/>
+          </a:prstGeom>
+          <a:noFill/>
+          <a:ln>
+            <a:noFill/>
+          </a:ln>
+        </p:spPr>
+        <p:txBody>
+          <a:bodyPr wrap="square" anchor="t" lIns="0" rIns="0" tIns="0" bIns="0"/>
+          <a:lstStyle/>
+          <a:p/>
+        </p:txBody>
+      </p:sp>
+      <p:sp>
+        <p:nvSpPr>
+          <p:cNvPr id="9" name="quote_text"/>
+          <p:cNvSpPr txBox="1"/>
+          <p:nvPr/>
+        </p:nvSpPr>
+        <p:spPr>
+          <a:xfrm>
+            <a:off x="566928" y="5669280"/>
+            <a:ext cx="11018520" cy="640080"/>
+          </a:xfrm>
+          <a:prstGeom prst="rect">
+            <a:avLst/>
+          </a:prstGeom>
+          <a:noFill/>
+          <a:ln>
+            <a:noFill/>
+          </a:ln>
+        </p:spPr>
+        <p:txBody>
+          <a:bodyPr wrap="square" anchor="t" lIns="0" rIns="0" tIns="0" bIns="0"/>
           <a:lstStyle/>
           <a:p/>
         </p:txBody>
@@ -4149,7 +4536,7 @@
     <p:bg>
       <p:bgPr>
         <a:solidFill>
-          <a:srgbClr val="F6F4EF"/>
+          <a:srgbClr val="F7F5F0"/>
         </a:solidFill>
         <a:effectLst/>
       </p:bgPr>
@@ -4170,17 +4557,18 @@
         <p:spPr>
           <a:xfrm>
             <a:off x="0" y="0"/>
-            <a:ext cx="109728" cy="6858000"/>
+            <a:ext cx="12191999" cy="73152"/>
           </a:xfrm>
           <a:prstGeom prst="rect">
             <a:avLst/>
           </a:prstGeom>
           <a:solidFill>
-            <a:srgbClr val="14324A"/>
+            <a:srgbClr val="17324D"/>
           </a:solidFill>
           <a:ln>
             <a:noFill/>
           </a:ln>
+          <a:effectLst/>
         </p:spPr>
         <p:style>
           <a:lnRef idx="1">
@@ -4206,14 +4594,14 @@
       </p:sp>
       <p:sp>
         <p:nvSpPr>
-          <p:cNvPr id="3" name="title_text"/>
+          <p:cNvPr id="3" name="tag_text"/>
           <p:cNvSpPr txBox="1"/>
           <p:nvPr/>
         </p:nvSpPr>
         <p:spPr>
           <a:xfrm>
-            <a:off x="502920" y="256032"/>
-            <a:ext cx="9509760" cy="713232"/>
+            <a:off x="566928" y="292608"/>
+            <a:ext cx="10789920" cy="256032"/>
           </a:xfrm>
           <a:prstGeom prst="rect">
             <a:avLst/>
@@ -4224,21 +4612,21 @@
           </a:ln>
         </p:spPr>
         <p:txBody>
-          <a:bodyPr wrap="square" anchor="t"/>
+          <a:bodyPr wrap="square" anchor="t" lIns="0" rIns="0" tIns="0" bIns="0"/>
           <a:lstStyle/>
           <a:p/>
         </p:txBody>
       </p:sp>
       <p:sp>
         <p:nvSpPr>
-          <p:cNvPr id="4" name="tag_text"/>
+          <p:cNvPr id="4" name="title_text"/>
           <p:cNvSpPr txBox="1"/>
           <p:nvPr/>
         </p:nvSpPr>
         <p:spPr>
           <a:xfrm>
-            <a:off x="502920" y="987552"/>
-            <a:ext cx="7772400" cy="292608"/>
+            <a:off x="566928" y="566928"/>
+            <a:ext cx="11018520" cy="868680"/>
           </a:xfrm>
           <a:prstGeom prst="rect">
             <a:avLst/>
@@ -4249,7 +4637,7 @@
           </a:ln>
         </p:spPr>
         <p:txBody>
-          <a:bodyPr wrap="square" anchor="t"/>
+          <a:bodyPr wrap="square" anchor="t" lIns="0" rIns="0" tIns="0" bIns="0"/>
           <a:lstStyle/>
           <a:p/>
         </p:txBody>
@@ -4262,8 +4650,8 @@
         </p:nvSpPr>
         <p:spPr>
           <a:xfrm>
-            <a:off x="502920" y="1335024"/>
-            <a:ext cx="2103120" cy="54864"/>
+            <a:off x="566928" y="1517904"/>
+            <a:ext cx="1417320" cy="41148"/>
           </a:xfrm>
           <a:prstGeom prst="rect">
             <a:avLst/>
@@ -4274,6 +4662,7 @@
           <a:ln>
             <a:noFill/>
           </a:ln>
+          <a:effectLst/>
         </p:spPr>
         <p:style>
           <a:lnRef idx="1">
@@ -4299,14 +4688,14 @@
       </p:sp>
       <p:sp>
         <p:nvSpPr>
-          <p:cNvPr id="6" name="body_text"/>
+          <p:cNvPr id="6" name="footer_text"/>
           <p:cNvSpPr txBox="1"/>
           <p:nvPr/>
         </p:nvSpPr>
         <p:spPr>
           <a:xfrm>
-            <a:off x="502920" y="1554480"/>
-            <a:ext cx="11064240" cy="3520440"/>
+            <a:off x="566928" y="6446520"/>
+            <a:ext cx="7680960" cy="256032"/>
           </a:xfrm>
           <a:prstGeom prst="rect">
             <a:avLst/>
@@ -4317,21 +4706,21 @@
           </a:ln>
         </p:spPr>
         <p:txBody>
-          <a:bodyPr wrap="square" anchor="t"/>
+          <a:bodyPr wrap="square" anchor="t" lIns="0" rIns="0" tIns="0" bIns="0"/>
           <a:lstStyle/>
           <a:p/>
         </p:txBody>
       </p:sp>
       <p:sp>
         <p:nvSpPr>
-          <p:cNvPr id="7" name="quote_text"/>
+          <p:cNvPr id="7" name="slide_number"/>
           <p:cNvSpPr txBox="1"/>
           <p:nvPr/>
         </p:nvSpPr>
         <p:spPr>
           <a:xfrm>
-            <a:off x="502920" y="5212080"/>
-            <a:ext cx="11064240" cy="1280160"/>
+            <a:off x="9281160" y="6446520"/>
+            <a:ext cx="2331720" cy="256032"/>
           </a:xfrm>
           <a:prstGeom prst="rect">
             <a:avLst/>
@@ -4342,7 +4731,59 @@
           </a:ln>
         </p:spPr>
         <p:txBody>
-          <a:bodyPr wrap="square" anchor="t"/>
+          <a:bodyPr wrap="square" anchor="t" lIns="0" rIns="0" tIns="0" bIns="0"/>
+          <a:lstStyle/>
+          <a:p>
+            <a:pPr algn="r"/>
+          </a:p>
+        </p:txBody>
+      </p:sp>
+      <p:sp>
+        <p:nvSpPr>
+          <p:cNvPr id="8" name="body_text"/>
+          <p:cNvSpPr txBox="1"/>
+          <p:nvPr/>
+        </p:nvSpPr>
+        <p:spPr>
+          <a:xfrm>
+            <a:off x="566928" y="1783080"/>
+            <a:ext cx="11018520" cy="3794760"/>
+          </a:xfrm>
+          <a:prstGeom prst="rect">
+            <a:avLst/>
+          </a:prstGeom>
+          <a:noFill/>
+          <a:ln>
+            <a:noFill/>
+          </a:ln>
+        </p:spPr>
+        <p:txBody>
+          <a:bodyPr wrap="square" anchor="t" lIns="0" rIns="0" tIns="0" bIns="0"/>
+          <a:lstStyle/>
+          <a:p/>
+        </p:txBody>
+      </p:sp>
+      <p:sp>
+        <p:nvSpPr>
+          <p:cNvPr id="9" name="quote_text"/>
+          <p:cNvSpPr txBox="1"/>
+          <p:nvPr/>
+        </p:nvSpPr>
+        <p:spPr>
+          <a:xfrm>
+            <a:off x="566928" y="5669280"/>
+            <a:ext cx="11018520" cy="640080"/>
+          </a:xfrm>
+          <a:prstGeom prst="rect">
+            <a:avLst/>
+          </a:prstGeom>
+          <a:noFill/>
+          <a:ln>
+            <a:noFill/>
+          </a:ln>
+        </p:spPr>
+        <p:txBody>
+          <a:bodyPr wrap="square" anchor="t" lIns="0" rIns="0" tIns="0" bIns="0"/>
           <a:lstStyle/>
           <a:p/>
         </p:txBody>

</xml_diff>

<commit_message>
style: align the deck to a left grid and restyle pain-point quotes
Keep the six-slide order and named shapes. Use Inter, a thin accent rule, and a large quotation mark instead of italic quote text.

Co-authored-by: VedantKachhawa <VedantKachhawa@users.noreply.github.com>
</commit_message>
<xml_diff>
--- a/backend/assets/template.pptx
+++ b/backend/assets/template.pptx
@@ -3089,7 +3089,7 @@
     <p:bg>
       <p:bgPr>
         <a:solidFill>
-          <a:srgbClr val="F7F5F0"/>
+          <a:srgbClr val="F6F7F8"/>
         </a:solidFill>
         <a:effectLst/>
       </p:bgPr>
@@ -3110,7 +3110,7 @@
         <p:spPr>
           <a:xfrm>
             <a:off x="0" y="0"/>
-            <a:ext cx="6583680" cy="6858000"/>
+            <a:ext cx="12191999" cy="73152"/>
           </a:xfrm>
           <a:prstGeom prst="rect">
             <a:avLst/>
@@ -3147,14 +3147,64 @@
       </p:sp>
       <p:sp>
         <p:nvSpPr>
-          <p:cNvPr id="3" name="divider"/>
+          <p:cNvPr id="3" name="tag_text"/>
+          <p:cNvSpPr txBox="1"/>
+          <p:nvPr/>
+        </p:nvSpPr>
+        <p:spPr>
+          <a:xfrm>
+            <a:off x="731520" y="347472"/>
+            <a:ext cx="10725912" cy="256032"/>
+          </a:xfrm>
+          <a:prstGeom prst="rect">
+            <a:avLst/>
+          </a:prstGeom>
+          <a:noFill/>
+          <a:ln>
+            <a:noFill/>
+          </a:ln>
+        </p:spPr>
+        <p:txBody>
+          <a:bodyPr wrap="square" anchor="t" lIns="0" rIns="0" tIns="0" bIns="0"/>
+          <a:lstStyle/>
+          <a:p/>
+        </p:txBody>
+      </p:sp>
+      <p:sp>
+        <p:nvSpPr>
+          <p:cNvPr id="4" name="title_text"/>
+          <p:cNvSpPr txBox="1"/>
+          <p:nvPr/>
+        </p:nvSpPr>
+        <p:spPr>
+          <a:xfrm>
+            <a:off x="731520" y="640080"/>
+            <a:ext cx="10725912" cy="804672"/>
+          </a:xfrm>
+          <a:prstGeom prst="rect">
+            <a:avLst/>
+          </a:prstGeom>
+          <a:noFill/>
+          <a:ln>
+            <a:noFill/>
+          </a:ln>
+        </p:spPr>
+        <p:txBody>
+          <a:bodyPr wrap="square" anchor="t" lIns="0" rIns="0" tIns="0" bIns="0"/>
+          <a:lstStyle/>
+          <a:p/>
+        </p:txBody>
+      </p:sp>
+      <p:sp>
+        <p:nvSpPr>
+          <p:cNvPr id="5" name="divider"/>
           <p:cNvSpPr/>
           <p:nvPr/>
         </p:nvSpPr>
         <p:spPr>
           <a:xfrm>
-            <a:off x="6583680" y="0"/>
-            <a:ext cx="64008" cy="6858000"/>
+            <a:off x="731520" y="1536192"/>
+            <a:ext cx="1554480" cy="36576"/>
           </a:xfrm>
           <a:prstGeom prst="rect">
             <a:avLst/>
@@ -3191,14 +3241,14 @@
       </p:sp>
       <p:sp>
         <p:nvSpPr>
-          <p:cNvPr id="4" name="tag_text"/>
+          <p:cNvPr id="6" name="footer_text"/>
           <p:cNvSpPr txBox="1"/>
           <p:nvPr/>
         </p:nvSpPr>
         <p:spPr>
           <a:xfrm>
-            <a:off x="502920" y="1554480"/>
-            <a:ext cx="5577840" cy="292608"/>
+            <a:off x="731520" y="6419088"/>
+            <a:ext cx="7315200" cy="256032"/>
           </a:xfrm>
           <a:prstGeom prst="rect">
             <a:avLst/>
@@ -3216,14 +3266,14 @@
       </p:sp>
       <p:sp>
         <p:nvSpPr>
-          <p:cNvPr id="5" name="title_text"/>
+          <p:cNvPr id="7" name="slide_number"/>
           <p:cNvSpPr txBox="1"/>
           <p:nvPr/>
         </p:nvSpPr>
         <p:spPr>
           <a:xfrm>
-            <a:off x="502920" y="1965960"/>
-            <a:ext cx="5669280" cy="2148840"/>
+            <a:off x="9052560" y="6419088"/>
+            <a:ext cx="2404872" cy="256032"/>
           </a:xfrm>
           <a:prstGeom prst="rect">
             <a:avLst/>
@@ -3236,19 +3286,21 @@
         <p:txBody>
           <a:bodyPr wrap="square" anchor="t" lIns="0" rIns="0" tIns="0" bIns="0"/>
           <a:lstStyle/>
-          <a:p/>
-        </p:txBody>
-      </p:sp>
-      <p:sp>
-        <p:nvSpPr>
-          <p:cNvPr id="6" name="body_text"/>
+          <a:p>
+            <a:pPr algn="r"/>
+          </a:p>
+        </p:txBody>
+      </p:sp>
+      <p:sp>
+        <p:nvSpPr>
+          <p:cNvPr id="8" name="body_text"/>
           <p:cNvSpPr txBox="1"/>
           <p:nvPr/>
         </p:nvSpPr>
         <p:spPr>
           <a:xfrm>
-            <a:off x="502920" y="4297680"/>
-            <a:ext cx="5623560" cy="1325880"/>
+            <a:off x="731520" y="1874519"/>
+            <a:ext cx="10725912" cy="1417320"/>
           </a:xfrm>
           <a:prstGeom prst="rect">
             <a:avLst/>
@@ -3266,14 +3318,14 @@
       </p:sp>
       <p:sp>
         <p:nvSpPr>
-          <p:cNvPr id="7" name="quote_text"/>
+          <p:cNvPr id="9" name="quote_text"/>
           <p:cNvSpPr txBox="1"/>
           <p:nvPr/>
         </p:nvSpPr>
         <p:spPr>
           <a:xfrm>
-            <a:off x="7040880" y="2331720"/>
-            <a:ext cx="4617720" cy="2377440"/>
+            <a:off x="731520" y="3566160"/>
+            <a:ext cx="10725912" cy="2286000"/>
           </a:xfrm>
           <a:prstGeom prst="rect">
             <a:avLst/>
@@ -3287,58 +3339,6 @@
           <a:bodyPr wrap="square" anchor="t" lIns="0" rIns="0" tIns="0" bIns="0"/>
           <a:lstStyle/>
           <a:p/>
-        </p:txBody>
-      </p:sp>
-      <p:sp>
-        <p:nvSpPr>
-          <p:cNvPr id="8" name="footer_text"/>
-          <p:cNvSpPr txBox="1"/>
-          <p:nvPr/>
-        </p:nvSpPr>
-        <p:spPr>
-          <a:xfrm>
-            <a:off x="7040880" y="6355080"/>
-            <a:ext cx="3017520" cy="256032"/>
-          </a:xfrm>
-          <a:prstGeom prst="rect">
-            <a:avLst/>
-          </a:prstGeom>
-          <a:noFill/>
-          <a:ln>
-            <a:noFill/>
-          </a:ln>
-        </p:spPr>
-        <p:txBody>
-          <a:bodyPr wrap="square" anchor="t" lIns="0" rIns="0" tIns="0" bIns="0"/>
-          <a:lstStyle/>
-          <a:p/>
-        </p:txBody>
-      </p:sp>
-      <p:sp>
-        <p:nvSpPr>
-          <p:cNvPr id="9" name="slide_number"/>
-          <p:cNvSpPr txBox="1"/>
-          <p:nvPr/>
-        </p:nvSpPr>
-        <p:spPr>
-          <a:xfrm>
-            <a:off x="9966960" y="6355080"/>
-            <a:ext cx="1691640" cy="256032"/>
-          </a:xfrm>
-          <a:prstGeom prst="rect">
-            <a:avLst/>
-          </a:prstGeom>
-          <a:noFill/>
-          <a:ln>
-            <a:noFill/>
-          </a:ln>
-        </p:spPr>
-        <p:txBody>
-          <a:bodyPr wrap="square" anchor="t" lIns="0" rIns="0" tIns="0" bIns="0"/>
-          <a:lstStyle/>
-          <a:p>
-            <a:pPr algn="r"/>
-          </a:p>
         </p:txBody>
       </p:sp>
     </p:spTree>
@@ -3355,7 +3355,7 @@
     <p:bg>
       <p:bgPr>
         <a:solidFill>
-          <a:srgbClr val="F7F5F0"/>
+          <a:srgbClr val="F6F7F8"/>
         </a:solidFill>
         <a:effectLst/>
       </p:bgPr>
@@ -3419,8 +3419,8 @@
         </p:nvSpPr>
         <p:spPr>
           <a:xfrm>
-            <a:off x="566928" y="292608"/>
-            <a:ext cx="10789920" cy="256032"/>
+            <a:off x="731520" y="347472"/>
+            <a:ext cx="10725912" cy="256032"/>
           </a:xfrm>
           <a:prstGeom prst="rect">
             <a:avLst/>
@@ -3444,8 +3444,8 @@
         </p:nvSpPr>
         <p:spPr>
           <a:xfrm>
-            <a:off x="566928" y="566928"/>
-            <a:ext cx="11018520" cy="868680"/>
+            <a:off x="731520" y="640080"/>
+            <a:ext cx="10725912" cy="804672"/>
           </a:xfrm>
           <a:prstGeom prst="rect">
             <a:avLst/>
@@ -3469,8 +3469,8 @@
         </p:nvSpPr>
         <p:spPr>
           <a:xfrm>
-            <a:off x="566928" y="1517904"/>
-            <a:ext cx="1417320" cy="41148"/>
+            <a:off x="731520" y="1536192"/>
+            <a:ext cx="1554480" cy="36576"/>
           </a:xfrm>
           <a:prstGeom prst="rect">
             <a:avLst/>
@@ -3513,8 +3513,8 @@
         </p:nvSpPr>
         <p:spPr>
           <a:xfrm>
-            <a:off x="566928" y="6446520"/>
-            <a:ext cx="7680960" cy="256032"/>
+            <a:off x="731520" y="6419088"/>
+            <a:ext cx="7315200" cy="256032"/>
           </a:xfrm>
           <a:prstGeom prst="rect">
             <a:avLst/>
@@ -3538,8 +3538,8 @@
         </p:nvSpPr>
         <p:spPr>
           <a:xfrm>
-            <a:off x="9281160" y="6446520"/>
-            <a:ext cx="2331720" cy="256032"/>
+            <a:off x="9052560" y="6419088"/>
+            <a:ext cx="2404872" cy="256032"/>
           </a:xfrm>
           <a:prstGeom prst="rect">
             <a:avLst/>
@@ -3565,8 +3565,8 @@
         </p:nvSpPr>
         <p:spPr>
           <a:xfrm>
-            <a:off x="566928" y="1783080"/>
-            <a:ext cx="6720840" cy="4343400"/>
+            <a:off x="731520" y="1828800"/>
+            <a:ext cx="6446520" cy="4160520"/>
           </a:xfrm>
           <a:prstGeom prst="rect">
             <a:avLst/>
@@ -3590,8 +3590,8 @@
         </p:nvSpPr>
         <p:spPr>
           <a:xfrm>
-            <a:off x="7498079" y="1783080"/>
-            <a:ext cx="4114800" cy="4343400"/>
+            <a:off x="7498079" y="1828800"/>
+            <a:ext cx="3959352" cy="4160520"/>
           </a:xfrm>
           <a:prstGeom prst="rect">
             <a:avLst/>
@@ -3634,8 +3634,8 @@
         </p:nvSpPr>
         <p:spPr>
           <a:xfrm>
-            <a:off x="7726679" y="1993392"/>
-            <a:ext cx="3703320" cy="3931920"/>
+            <a:off x="7754112" y="2048256"/>
+            <a:ext cx="3520440" cy="3749039"/>
           </a:xfrm>
           <a:prstGeom prst="rect">
             <a:avLst/>
@@ -3665,7 +3665,7 @@
     <p:bg>
       <p:bgPr>
         <a:solidFill>
-          <a:srgbClr val="F7F5F0"/>
+          <a:srgbClr val="F6F7F8"/>
         </a:solidFill>
         <a:effectLst/>
       </p:bgPr>
@@ -3729,8 +3729,8 @@
         </p:nvSpPr>
         <p:spPr>
           <a:xfrm>
-            <a:off x="566928" y="292608"/>
-            <a:ext cx="10789920" cy="256032"/>
+            <a:off x="731520" y="347472"/>
+            <a:ext cx="10725912" cy="256032"/>
           </a:xfrm>
           <a:prstGeom prst="rect">
             <a:avLst/>
@@ -3754,8 +3754,8 @@
         </p:nvSpPr>
         <p:spPr>
           <a:xfrm>
-            <a:off x="566928" y="566928"/>
-            <a:ext cx="11018520" cy="868680"/>
+            <a:off x="731520" y="640080"/>
+            <a:ext cx="10725912" cy="804672"/>
           </a:xfrm>
           <a:prstGeom prst="rect">
             <a:avLst/>
@@ -3779,8 +3779,8 @@
         </p:nvSpPr>
         <p:spPr>
           <a:xfrm>
-            <a:off x="566928" y="1517904"/>
-            <a:ext cx="1417320" cy="41148"/>
+            <a:off x="731520" y="1536192"/>
+            <a:ext cx="1554480" cy="36576"/>
           </a:xfrm>
           <a:prstGeom prst="rect">
             <a:avLst/>
@@ -3823,8 +3823,8 @@
         </p:nvSpPr>
         <p:spPr>
           <a:xfrm>
-            <a:off x="566928" y="6446520"/>
-            <a:ext cx="7680960" cy="256032"/>
+            <a:off x="731520" y="6419088"/>
+            <a:ext cx="7315200" cy="256032"/>
           </a:xfrm>
           <a:prstGeom prst="rect">
             <a:avLst/>
@@ -3848,8 +3848,8 @@
         </p:nvSpPr>
         <p:spPr>
           <a:xfrm>
-            <a:off x="9281160" y="6446520"/>
-            <a:ext cx="2331720" cy="256032"/>
+            <a:off x="9052560" y="6419088"/>
+            <a:ext cx="2404872" cy="256032"/>
           </a:xfrm>
           <a:prstGeom prst="rect">
             <a:avLst/>
@@ -3875,8 +3875,8 @@
         </p:nvSpPr>
         <p:spPr>
           <a:xfrm>
-            <a:off x="566928" y="1737360"/>
-            <a:ext cx="11018520" cy="1554480"/>
+            <a:off x="731520" y="1783080"/>
+            <a:ext cx="10725912" cy="1325880"/>
           </a:xfrm>
           <a:prstGeom prst="rect">
             <a:avLst/>
@@ -3900,14 +3900,14 @@
         </p:nvSpPr>
         <p:spPr>
           <a:xfrm>
-            <a:off x="566928" y="3520440"/>
-            <a:ext cx="11018520" cy="2651760"/>
+            <a:off x="731520" y="3383280"/>
+            <a:ext cx="45720" cy="2331720"/>
           </a:xfrm>
           <a:prstGeom prst="rect">
             <a:avLst/>
           </a:prstGeom>
           <a:solidFill>
-            <a:srgbClr val="FFFFFF"/>
+            <a:srgbClr val="C46B3A"/>
           </a:solidFill>
           <a:ln>
             <a:noFill/>
@@ -3944,8 +3944,8 @@
         </p:nvSpPr>
         <p:spPr>
           <a:xfrm>
-            <a:off x="749808" y="3611880"/>
-            <a:ext cx="640080" cy="548640"/>
+            <a:off x="987552" y="3218688"/>
+            <a:ext cx="777240" cy="777240"/>
           </a:xfrm>
           <a:prstGeom prst="rect">
             <a:avLst/>
@@ -3960,6 +3960,14 @@
           <a:lstStyle/>
           <a:p>
             <a:r>
+              <a:rPr sz="5400" b="1" i="0">
+                <a:solidFill>
+                  <a:srgbClr val="C46B3A"/>
+                </a:solidFill>
+                <a:latin typeface="Inter"/>
+                <a:cs typeface="Inter"/>
+                <a:ea typeface="Inter"/>
+              </a:rPr>
               <a:t>“</a:t>
             </a:r>
           </a:p>
@@ -3973,8 +3981,8 @@
         </p:nvSpPr>
         <p:spPr>
           <a:xfrm>
-            <a:off x="1325880" y="3794760"/>
-            <a:ext cx="9921240" cy="2148840"/>
+            <a:off x="1783080" y="3794760"/>
+            <a:ext cx="9491472" cy="1874519"/>
           </a:xfrm>
           <a:prstGeom prst="rect">
             <a:avLst/>
@@ -4004,7 +4012,7 @@
     <p:bg>
       <p:bgPr>
         <a:solidFill>
-          <a:srgbClr val="F7F5F0"/>
+          <a:srgbClr val="F6F7F8"/>
         </a:solidFill>
         <a:effectLst/>
       </p:bgPr>
@@ -4068,8 +4076,8 @@
         </p:nvSpPr>
         <p:spPr>
           <a:xfrm>
-            <a:off x="566928" y="292608"/>
-            <a:ext cx="10789920" cy="256032"/>
+            <a:off x="731520" y="347472"/>
+            <a:ext cx="10725912" cy="256032"/>
           </a:xfrm>
           <a:prstGeom prst="rect">
             <a:avLst/>
@@ -4093,8 +4101,8 @@
         </p:nvSpPr>
         <p:spPr>
           <a:xfrm>
-            <a:off x="566928" y="566928"/>
-            <a:ext cx="11018520" cy="868680"/>
+            <a:off x="731520" y="640080"/>
+            <a:ext cx="10725912" cy="804672"/>
           </a:xfrm>
           <a:prstGeom prst="rect">
             <a:avLst/>
@@ -4118,8 +4126,8 @@
         </p:nvSpPr>
         <p:spPr>
           <a:xfrm>
-            <a:off x="566928" y="1517904"/>
-            <a:ext cx="1417320" cy="41148"/>
+            <a:off x="731520" y="1536192"/>
+            <a:ext cx="1554480" cy="36576"/>
           </a:xfrm>
           <a:prstGeom prst="rect">
             <a:avLst/>
@@ -4162,8 +4170,8 @@
         </p:nvSpPr>
         <p:spPr>
           <a:xfrm>
-            <a:off x="566928" y="6446520"/>
-            <a:ext cx="7680960" cy="256032"/>
+            <a:off x="731520" y="6419088"/>
+            <a:ext cx="7315200" cy="256032"/>
           </a:xfrm>
           <a:prstGeom prst="rect">
             <a:avLst/>
@@ -4187,8 +4195,8 @@
         </p:nvSpPr>
         <p:spPr>
           <a:xfrm>
-            <a:off x="9281160" y="6446520"/>
-            <a:ext cx="2331720" cy="256032"/>
+            <a:off x="9052560" y="6419088"/>
+            <a:ext cx="2404872" cy="256032"/>
           </a:xfrm>
           <a:prstGeom prst="rect">
             <a:avLst/>
@@ -4214,8 +4222,8 @@
         </p:nvSpPr>
         <p:spPr>
           <a:xfrm>
-            <a:off x="566928" y="1719072"/>
-            <a:ext cx="11018520" cy="502920"/>
+            <a:off x="731520" y="1783080"/>
+            <a:ext cx="10725912" cy="457200"/>
           </a:xfrm>
           <a:prstGeom prst="rect">
             <a:avLst/>
@@ -4239,8 +4247,8 @@
         </p:nvSpPr>
         <p:spPr>
           <a:xfrm>
-            <a:off x="566928" y="5989320"/>
-            <a:ext cx="11018520" cy="347472"/>
+            <a:off x="731520" y="5943600"/>
+            <a:ext cx="10725912" cy="347472"/>
           </a:xfrm>
           <a:prstGeom prst="rect">
             <a:avLst/>
@@ -4270,7 +4278,7 @@
     <p:bg>
       <p:bgPr>
         <a:solidFill>
-          <a:srgbClr val="F7F5F0"/>
+          <a:srgbClr val="F6F7F8"/>
         </a:solidFill>
         <a:effectLst/>
       </p:bgPr>
@@ -4334,8 +4342,8 @@
         </p:nvSpPr>
         <p:spPr>
           <a:xfrm>
-            <a:off x="566928" y="292608"/>
-            <a:ext cx="10789920" cy="256032"/>
+            <a:off x="731520" y="347472"/>
+            <a:ext cx="10725912" cy="256032"/>
           </a:xfrm>
           <a:prstGeom prst="rect">
             <a:avLst/>
@@ -4359,8 +4367,8 @@
         </p:nvSpPr>
         <p:spPr>
           <a:xfrm>
-            <a:off x="566928" y="566928"/>
-            <a:ext cx="11018520" cy="868680"/>
+            <a:off x="731520" y="640080"/>
+            <a:ext cx="10725912" cy="804672"/>
           </a:xfrm>
           <a:prstGeom prst="rect">
             <a:avLst/>
@@ -4384,8 +4392,8 @@
         </p:nvSpPr>
         <p:spPr>
           <a:xfrm>
-            <a:off x="566928" y="1517904"/>
-            <a:ext cx="1417320" cy="41148"/>
+            <a:off x="731520" y="1536192"/>
+            <a:ext cx="1554480" cy="36576"/>
           </a:xfrm>
           <a:prstGeom prst="rect">
             <a:avLst/>
@@ -4428,8 +4436,8 @@
         </p:nvSpPr>
         <p:spPr>
           <a:xfrm>
-            <a:off x="566928" y="6446520"/>
-            <a:ext cx="7680960" cy="256032"/>
+            <a:off x="731520" y="6419088"/>
+            <a:ext cx="7315200" cy="256032"/>
           </a:xfrm>
           <a:prstGeom prst="rect">
             <a:avLst/>
@@ -4453,8 +4461,8 @@
         </p:nvSpPr>
         <p:spPr>
           <a:xfrm>
-            <a:off x="9281160" y="6446520"/>
-            <a:ext cx="2331720" cy="256032"/>
+            <a:off x="9052560" y="6419088"/>
+            <a:ext cx="2404872" cy="256032"/>
           </a:xfrm>
           <a:prstGeom prst="rect">
             <a:avLst/>
@@ -4480,8 +4488,8 @@
         </p:nvSpPr>
         <p:spPr>
           <a:xfrm>
-            <a:off x="566928" y="1783080"/>
-            <a:ext cx="11018520" cy="3794760"/>
+            <a:off x="731520" y="1828800"/>
+            <a:ext cx="10725912" cy="3657600"/>
           </a:xfrm>
           <a:prstGeom prst="rect">
             <a:avLst/>
@@ -4505,8 +4513,8 @@
         </p:nvSpPr>
         <p:spPr>
           <a:xfrm>
-            <a:off x="566928" y="5669280"/>
-            <a:ext cx="11018520" cy="640080"/>
+            <a:off x="731520" y="5623560"/>
+            <a:ext cx="10725912" cy="640080"/>
           </a:xfrm>
           <a:prstGeom prst="rect">
             <a:avLst/>
@@ -4536,7 +4544,7 @@
     <p:bg>
       <p:bgPr>
         <a:solidFill>
-          <a:srgbClr val="F7F5F0"/>
+          <a:srgbClr val="F6F7F8"/>
         </a:solidFill>
         <a:effectLst/>
       </p:bgPr>
@@ -4600,8 +4608,8 @@
         </p:nvSpPr>
         <p:spPr>
           <a:xfrm>
-            <a:off x="566928" y="292608"/>
-            <a:ext cx="10789920" cy="256032"/>
+            <a:off x="731520" y="347472"/>
+            <a:ext cx="10725912" cy="256032"/>
           </a:xfrm>
           <a:prstGeom prst="rect">
             <a:avLst/>
@@ -4625,8 +4633,8 @@
         </p:nvSpPr>
         <p:spPr>
           <a:xfrm>
-            <a:off x="566928" y="566928"/>
-            <a:ext cx="11018520" cy="868680"/>
+            <a:off x="731520" y="640080"/>
+            <a:ext cx="10725912" cy="804672"/>
           </a:xfrm>
           <a:prstGeom prst="rect">
             <a:avLst/>
@@ -4650,8 +4658,8 @@
         </p:nvSpPr>
         <p:spPr>
           <a:xfrm>
-            <a:off x="566928" y="1517904"/>
-            <a:ext cx="1417320" cy="41148"/>
+            <a:off x="731520" y="1536192"/>
+            <a:ext cx="1554480" cy="36576"/>
           </a:xfrm>
           <a:prstGeom prst="rect">
             <a:avLst/>
@@ -4694,8 +4702,8 @@
         </p:nvSpPr>
         <p:spPr>
           <a:xfrm>
-            <a:off x="566928" y="6446520"/>
-            <a:ext cx="7680960" cy="256032"/>
+            <a:off x="731520" y="6419088"/>
+            <a:ext cx="7315200" cy="256032"/>
           </a:xfrm>
           <a:prstGeom prst="rect">
             <a:avLst/>
@@ -4719,8 +4727,8 @@
         </p:nvSpPr>
         <p:spPr>
           <a:xfrm>
-            <a:off x="9281160" y="6446520"/>
-            <a:ext cx="2331720" cy="256032"/>
+            <a:off x="9052560" y="6419088"/>
+            <a:ext cx="2404872" cy="256032"/>
           </a:xfrm>
           <a:prstGeom prst="rect">
             <a:avLst/>
@@ -4746,8 +4754,8 @@
         </p:nvSpPr>
         <p:spPr>
           <a:xfrm>
-            <a:off x="566928" y="1783080"/>
-            <a:ext cx="11018520" cy="3794760"/>
+            <a:off x="731520" y="1828800"/>
+            <a:ext cx="10725912" cy="3657600"/>
           </a:xfrm>
           <a:prstGeom prst="rect">
             <a:avLst/>
@@ -4771,8 +4779,8 @@
         </p:nvSpPr>
         <p:spPr>
           <a:xfrm>
-            <a:off x="566928" y="5669280"/>
-            <a:ext cx="11018520" cy="640080"/>
+            <a:off x="731520" y="5623560"/>
+            <a:ext cx="10725912" cy="640080"/>
           </a:xfrm>
           <a:prstGeom prst="rect">
             <a:avLst/>

</xml_diff>